<commit_message>
docs(aca): add contract source references to all verification claims
- Every assertion now cites exact Ziffer, page, and verbatim text
- Ebene 4 error: 4 separate contract references proving 'Brücke'
- Cost split: Ziff. 15 (Invest) + Ziff. 17 (45%/55% with area calc)
- Vertragsbeginn: Ziff. 29 + S.13 signatures + document code
</commit_message>
<xml_diff>
--- a/whomakestherules/A38_H4R2026_Ch7.pptx
+++ b/whomakestherules/A38_H4R2026_Ch7.pptx
@@ -5,15 +5,15 @@
     <p:sldMasterId id="2147483648" r:id="rId4"/>
   </p:sldMasterIdLst>
   <p:sldIdLst>
-    <p:sldId id="256" r:id="rId6"/>
-    <p:sldId id="257" r:id="rId5"/>
-    <p:sldId id="258" r:id="rId11"/>
-    <p:sldId id="259" r:id="rId12"/>
-    <p:sldId id="260" r:id="rId13"/>
-    <p:sldId id="261" r:id="rId14"/>
-    <p:sldId id="262" r:id="rId15"/>
-    <p:sldId id="263" r:id="rId16"/>
-    <p:sldId id="264" r:id="rId17"/>
+    <p:sldId id="256" r:id="rId5"/>
+    <p:sldId id="257" r:id="rId6"/>
+    <p:sldId id="258" r:id="rId7"/>
+    <p:sldId id="259" r:id="rId8"/>
+    <p:sldId id="260" r:id="rId9"/>
+    <p:sldId id="261" r:id="rId10"/>
+    <p:sldId id="262" r:id="rId11"/>
+    <p:sldId id="263" r:id="rId12"/>
+    <p:sldId id="264" r:id="rId13"/>
   </p:sldIdLst>
   <p:sldSz cx="12192000" cy="6858000"/>
   <p:notesSz cx="6858000" cy="9144000"/>
@@ -3420,7 +3420,7 @@
 </file>
 
 <file path=ppt/slides/slide1.xml><?xml version="1.0" encoding="utf-8"?>
-<p:sld xmlns:a="http://schemas.openxmlformats.org/drawingml/2006/main" xmlns:p="http://schemas.openxmlformats.org/presentationml/2006/main" xmlns:r="http://schemas.openxmlformats.org/officeDocument/2006/relationships">
+<p:sld xmlns:a="http://schemas.openxmlformats.org/drawingml/2006/main" xmlns:r="http://schemas.openxmlformats.org/officeDocument/2006/relationships" xmlns:p="http://schemas.openxmlformats.org/presentationml/2006/main">
   <p:cSld>
     <p:spTree>
       <p:nvGrpSpPr>
@@ -3428,7 +3428,14 @@
         <p:cNvGrpSpPr/>
         <p:nvPr/>
       </p:nvGrpSpPr>
-      <p:grpSpPr/>
+      <p:grpSpPr>
+        <a:xfrm>
+          <a:off x="0" y="0"/>
+          <a:ext cx="0" cy="0"/>
+          <a:chOff x="0" y="0"/>
+          <a:chExt cx="0" cy="0"/>
+        </a:xfrm>
+      </p:grpSpPr>
       <p:sp>
         <p:nvSpPr>
           <p:cNvPr id="2" name="Title 1"/>
@@ -3466,11 +3473,13 @@
           <a:lstStyle/>
           <a:p>
             <a:r>
+              <a:rPr dirty="0"/>
               <a:t>Machine-Readable Railway Governance</a:t>
             </a:r>
           </a:p>
           <a:p>
             <a:r>
+              <a:rPr dirty="0"/>
               <a:t>Hack4Rail 2026 – Team A38</a:t>
             </a:r>
           </a:p>
@@ -3485,7 +3494,7 @@
 </file>
 
 <file path=ppt/slides/slide2.xml><?xml version="1.0" encoding="utf-8"?>
-<p:sld xmlns:a="http://schemas.openxmlformats.org/drawingml/2006/main" xmlns:p="http://schemas.openxmlformats.org/presentationml/2006/main" xmlns:r="http://schemas.openxmlformats.org/officeDocument/2006/relationships">
+<p:sld xmlns:a="http://schemas.openxmlformats.org/drawingml/2006/main" xmlns:r="http://schemas.openxmlformats.org/officeDocument/2006/relationships" xmlns:p="http://schemas.openxmlformats.org/presentationml/2006/main">
   <p:cSld>
     <p:spTree>
       <p:nvGrpSpPr>
@@ -3493,7 +3502,14 @@
         <p:cNvGrpSpPr/>
         <p:nvPr/>
       </p:nvGrpSpPr>
-      <p:grpSpPr/>
+      <p:grpSpPr>
+        <a:xfrm>
+          <a:off x="0" y="0"/>
+          <a:ext cx="0" cy="0"/>
+          <a:chOff x="0" y="0"/>
+          <a:chExt cx="0" cy="0"/>
+        </a:xfrm>
+      </p:grpSpPr>
       <p:sp>
         <p:nvSpPr>
           <p:cNvPr id="2" name="Title 1"/>
@@ -3527,37 +3543,97 @@
         </p:nvSpPr>
         <p:spPr/>
         <p:txBody>
-          <a:bodyPr/>
-          <a:lstStyle/>
-          <a:p>
-            <a:r>
+          <a:bodyPr>
+            <a:normAutofit fontScale="92500" lnSpcReduction="20000"/>
+          </a:bodyPr>
+          <a:lstStyle/>
+          <a:p>
+            <a:r>
+              <a:rPr dirty="0"/>
               <a:t>📦 "Here are the regulations. Read them. All of them."</a:t>
             </a:r>
-          </a:p>
-          <a:p/>
-          <a:p>
-            <a:r>
+            <a:endParaRPr lang="de-DE" dirty="0"/>
+          </a:p>
+          <a:p>
+            <a:r>
+              <a:rPr lang="de-DE" dirty="0"/>
+              <a:t>„</a:t>
+            </a:r>
+            <a:r>
+              <a:rPr lang="de-DE" dirty="0" err="1"/>
+              <a:t>Apply</a:t>
+            </a:r>
+            <a:r>
+              <a:rPr lang="de-DE" dirty="0"/>
+              <a:t> </a:t>
+            </a:r>
+            <a:r>
+              <a:rPr lang="de-DE" dirty="0" err="1"/>
+              <a:t>them</a:t>
+            </a:r>
+            <a:r>
+              <a:rPr lang="de-DE" dirty="0"/>
+              <a:t>“</a:t>
+            </a:r>
+            <a:endParaRPr dirty="0"/>
+          </a:p>
+          <a:p>
+            <a:endParaRPr dirty="0"/>
+          </a:p>
+          <a:p>
+            <a:r>
+              <a:rPr dirty="0"/>
               <a:t>📦📦 "Here's the new version. Compare it.</a:t>
             </a:r>
           </a:p>
           <a:p>
             <a:r>
+              <a:rPr dirty="0"/>
               <a:t>      Tell me what changed."</a:t>
             </a:r>
-          </a:p>
-          <a:p/>
-          <a:p>
-            <a:r>
+            <a:endParaRPr lang="de-DE" dirty="0"/>
+          </a:p>
+          <a:p>
+            <a:r>
+              <a:rPr lang="de-DE" dirty="0"/>
+              <a:t>„</a:t>
+            </a:r>
+            <a:r>
+              <a:rPr lang="de-DE" dirty="0" err="1"/>
+              <a:t>Apply</a:t>
+            </a:r>
+            <a:r>
+              <a:rPr lang="de-DE" dirty="0"/>
+              <a:t> </a:t>
+            </a:r>
+            <a:r>
+              <a:rPr lang="de-DE" dirty="0" err="1"/>
+              <a:t>them</a:t>
+            </a:r>
+            <a:r>
+              <a:rPr lang="de-DE" dirty="0"/>
+              <a:t>“</a:t>
+            </a:r>
+            <a:endParaRPr dirty="0"/>
+          </a:p>
+          <a:p>
+            <a:endParaRPr dirty="0"/>
+          </a:p>
+          <a:p>
+            <a:r>
+              <a:rPr dirty="0"/>
               <a:t>This is what railway companies do today.</a:t>
             </a:r>
           </a:p>
           <a:p>
             <a:r>
+              <a:rPr dirty="0"/>
               <a:t>Manually. For hundreds of rules.</a:t>
             </a:r>
           </a:p>
           <a:p>
             <a:r>
+              <a:rPr dirty="0"/>
               <a:t>Across multiple countries and languages.</a:t>
             </a:r>
           </a:p>
@@ -3572,7 +3648,7 @@
 </file>
 
 <file path=ppt/slides/slide3.xml><?xml version="1.0" encoding="utf-8"?>
-<p:sld xmlns:a="http://schemas.openxmlformats.org/drawingml/2006/main" xmlns:p="http://schemas.openxmlformats.org/presentationml/2006/main" xmlns:r="http://schemas.openxmlformats.org/officeDocument/2006/relationships">
+<p:sld xmlns:a="http://schemas.openxmlformats.org/drawingml/2006/main" xmlns:r="http://schemas.openxmlformats.org/officeDocument/2006/relationships" xmlns:p="http://schemas.openxmlformats.org/presentationml/2006/main">
   <p:cSld>
     <p:spTree>
       <p:nvGrpSpPr>
@@ -3580,7 +3656,14 @@
         <p:cNvGrpSpPr/>
         <p:nvPr/>
       </p:nvGrpSpPr>
-      <p:grpSpPr/>
+      <p:grpSpPr>
+        <a:xfrm>
+          <a:off x="0" y="0"/>
+          <a:ext cx="0" cy="0"/>
+          <a:chOff x="0" y="0"/>
+          <a:chExt cx="0" cy="0"/>
+        </a:xfrm>
+      </p:grpSpPr>
       <p:sp>
         <p:nvSpPr>
           <p:cNvPr id="2" name="Title 1"/>
@@ -3626,7 +3709,9 @@
               <a:t>  Word → PDF → humans extract what applies</a:t>
             </a:r>
           </a:p>
-          <a:p/>
+          <a:p>
+            <a:endParaRPr/>
+          </a:p>
           <a:p>
             <a:r>
               <a:t>OUR PROPOSAL:</a:t>
@@ -3647,7 +3732,9 @@
               <a:t>  The PDF is a generated view.</a:t>
             </a:r>
           </a:p>
-          <a:p/>
+          <a:p>
+            <a:endParaRPr/>
+          </a:p>
           <a:p>
             <a:r>
               <a:t>NIST does it (OSCAL). BSI adopted it.</a:t>
@@ -3669,7 +3756,7 @@
 </file>
 
 <file path=ppt/slides/slide4.xml><?xml version="1.0" encoding="utf-8"?>
-<p:sld xmlns:a="http://schemas.openxmlformats.org/drawingml/2006/main" xmlns:p="http://schemas.openxmlformats.org/presentationml/2006/main" xmlns:r="http://schemas.openxmlformats.org/officeDocument/2006/relationships">
+<p:sld xmlns:a="http://schemas.openxmlformats.org/drawingml/2006/main" xmlns:r="http://schemas.openxmlformats.org/officeDocument/2006/relationships" xmlns:p="http://schemas.openxmlformats.org/presentationml/2006/main">
   <p:cSld>
     <p:spTree>
       <p:nvGrpSpPr>
@@ -3677,7 +3764,14 @@
         <p:cNvGrpSpPr/>
         <p:nvPr/>
       </p:nvGrpSpPr>
-      <p:grpSpPr/>
+      <p:grpSpPr>
+        <a:xfrm>
+          <a:off x="0" y="0"/>
+          <a:ext cx="0" cy="0"/>
+          <a:chOff x="0" y="0"/>
+          <a:chExt cx="0" cy="0"/>
+        </a:xfrm>
+      </p:grpSpPr>
       <p:sp>
         <p:nvSpPr>
           <p:cNvPr id="2" name="Title 1"/>
@@ -3718,7 +3812,9 @@
               <a:t>Lightweight profile of NIST OSCAL for railway regulations</a:t>
             </a:r>
           </a:p>
-          <a:p/>
+          <a:p>
+            <a:endParaRPr/>
+          </a:p>
           <a:p>
             <a:r>
               <a:t>Catalog → Groups → Controls</a:t>
@@ -3739,7 +3835,9 @@
               <a:t>  └─ One regulation</a:t>
             </a:r>
           </a:p>
-          <a:p/>
+          <a:p>
+            <a:endParaRPr/>
+          </a:p>
           <a:p>
             <a:r>
               <a:t>Key features:</a:t>
@@ -3776,7 +3874,7 @@
 </file>
 
 <file path=ppt/slides/slide5.xml><?xml version="1.0" encoding="utf-8"?>
-<p:sld xmlns:a="http://schemas.openxmlformats.org/drawingml/2006/main" xmlns:p="http://schemas.openxmlformats.org/presentationml/2006/main" xmlns:r="http://schemas.openxmlformats.org/officeDocument/2006/relationships">
+<p:sld xmlns:a="http://schemas.openxmlformats.org/drawingml/2006/main" xmlns:r="http://schemas.openxmlformats.org/officeDocument/2006/relationships" xmlns:p="http://schemas.openxmlformats.org/presentationml/2006/main">
   <p:cSld>
     <p:spTree>
       <p:nvGrpSpPr>
@@ -3784,7 +3882,14 @@
         <p:cNvGrpSpPr/>
         <p:nvPr/>
       </p:nvGrpSpPr>
-      <p:grpSpPr/>
+      <p:grpSpPr>
+        <a:xfrm>
+          <a:off x="0" y="0"/>
+          <a:ext cx="0" cy="0"/>
+          <a:chOff x="0" y="0"/>
+          <a:chExt cx="0" cy="0"/>
+        </a:xfrm>
+      </p:grpSpPr>
       <p:sp>
         <p:nvSpPr>
           <p:cNvPr id="2" name="Title 1"/>
@@ -3830,7 +3935,9 @@
               <a:t>44 rules × 6 channels × 4 transport modes</a:t>
             </a:r>
           </a:p>
-          <a:p/>
+          <a:p>
+            <a:endParaRPr/>
+          </a:p>
           <a:p>
             <a:r>
               <a:t>What we did:</a:t>
@@ -3856,7 +3963,9 @@
               <a:t>• Validated against NIST JSON Schema ✅</a:t>
             </a:r>
           </a:p>
-          <a:p/>
+          <a:p>
+            <a:endParaRPr/>
+          </a:p>
           <a:p>
             <a:r>
               <a:t>What changed between 2024 and 2025?</a:t>
@@ -3878,7 +3987,7 @@
 </file>
 
 <file path=ppt/slides/slide6.xml><?xml version="1.0" encoding="utf-8"?>
-<p:sld xmlns:a="http://schemas.openxmlformats.org/drawingml/2006/main" xmlns:p="http://schemas.openxmlformats.org/presentationml/2006/main" xmlns:r="http://schemas.openxmlformats.org/officeDocument/2006/relationships">
+<p:sld xmlns:a="http://schemas.openxmlformats.org/drawingml/2006/main" xmlns:r="http://schemas.openxmlformats.org/officeDocument/2006/relationships" xmlns:p="http://schemas.openxmlformats.org/presentationml/2006/main">
   <p:cSld>
     <p:spTree>
       <p:nvGrpSpPr>
@@ -3886,7 +3995,14 @@
         <p:cNvGrpSpPr/>
         <p:nvPr/>
       </p:nvGrpSpPr>
-      <p:grpSpPr/>
+      <p:grpSpPr>
+        <a:xfrm>
+          <a:off x="0" y="0"/>
+          <a:ext cx="0" cy="0"/>
+          <a:chOff x="0" y="0"/>
+          <a:chExt cx="0" cy="0"/>
+        </a:xfrm>
+      </p:grpSpPr>
       <p:sp>
         <p:nvSpPr>
           <p:cNvPr id="2" name="Title 1"/>
@@ -3927,7 +4043,9 @@
               <a:t>Because it's in Git:</a:t>
             </a:r>
           </a:p>
-          <a:p/>
+          <a:p>
+            <a:endParaRPr/>
+          </a:p>
           <a:p>
             <a:r>
               <a:t>• Full version history of every rule</a:t>
@@ -3948,7 +4066,9 @@
               <a:t>• Audit trail: who approved what</a:t>
             </a:r>
           </a:p>
-          <a:p/>
+          <a:p>
+            <a:endParaRPr/>
+          </a:p>
           <a:p>
             <a:r>
               <a:t>No more: "Which version is current?"</a:t>
@@ -3970,7 +4090,7 @@
 </file>
 
 <file path=ppt/slides/slide7.xml><?xml version="1.0" encoding="utf-8"?>
-<p:sld xmlns:a="http://schemas.openxmlformats.org/drawingml/2006/main" xmlns:p="http://schemas.openxmlformats.org/presentationml/2006/main" xmlns:r="http://schemas.openxmlformats.org/officeDocument/2006/relationships">
+<p:sld xmlns:a="http://schemas.openxmlformats.org/drawingml/2006/main" xmlns:r="http://schemas.openxmlformats.org/officeDocument/2006/relationships" xmlns:p="http://schemas.openxmlformats.org/presentationml/2006/main">
   <p:cSld>
     <p:spTree>
       <p:nvGrpSpPr>
@@ -3978,7 +4098,14 @@
         <p:cNvGrpSpPr/>
         <p:nvPr/>
       </p:nvGrpSpPr>
-      <p:grpSpPr/>
+      <p:grpSpPr>
+        <a:xfrm>
+          <a:off x="0" y="0"/>
+          <a:ext cx="0" cy="0"/>
+          <a:chOff x="0" y="0"/>
+          <a:chExt cx="0" cy="0"/>
+        </a:xfrm>
+      </p:grpSpPr>
       <p:sp>
         <p:nvSpPr>
           <p:cNvPr id="2" name="Title 1"/>
@@ -4024,7 +4151,9 @@
               <a:t>   (already structured, digital-native)</a:t>
             </a:r>
           </a:p>
-          <a:p/>
+          <a:p>
+            <a:endParaRPr/>
+          </a:p>
           <a:p>
             <a:r>
               <a:t>2. Web editor that behaves like Word</a:t>
@@ -4035,7 +4164,9 @@
               <a:t>   (low learning curve for governance owners)</a:t>
             </a:r>
           </a:p>
-          <a:p/>
+          <a:p>
+            <a:endParaRPr/>
+          </a:p>
           <a:p>
             <a:r>
               <a:t>3. Import existing governance documents</a:t>
@@ -4046,7 +4177,9 @@
               <a:t>   → validate → publish as OSCAL</a:t>
             </a:r>
           </a:p>
-          <a:p/>
+          <a:p>
+            <a:endParaRPr/>
+          </a:p>
           <a:p>
             <a:r>
               <a:t>4. Expand: safety regulations, cross-border (TSI),</a:t>
@@ -4057,7 +4190,9 @@
               <a:t>   operational rules</a:t>
             </a:r>
           </a:p>
-          <a:p/>
+          <a:p>
+            <a:endParaRPr/>
+          </a:p>
           <a:p>
             <a:r>
               <a:t>Little change in workflow. Massive gain in usability.</a:t>
@@ -4074,7 +4209,7 @@
 </file>
 
 <file path=ppt/slides/slide8.xml><?xml version="1.0" encoding="utf-8"?>
-<p:sld xmlns:a="http://schemas.openxmlformats.org/drawingml/2006/main" xmlns:p="http://schemas.openxmlformats.org/presentationml/2006/main" xmlns:r="http://schemas.openxmlformats.org/officeDocument/2006/relationships">
+<p:sld xmlns:a="http://schemas.openxmlformats.org/drawingml/2006/main" xmlns:r="http://schemas.openxmlformats.org/officeDocument/2006/relationships" xmlns:p="http://schemas.openxmlformats.org/presentationml/2006/main">
   <p:cSld>
     <p:spTree>
       <p:nvGrpSpPr>
@@ -4082,7 +4217,14 @@
         <p:cNvGrpSpPr/>
         <p:nvPr/>
       </p:nvGrpSpPr>
-      <p:grpSpPr/>
+      <p:grpSpPr>
+        <a:xfrm>
+          <a:off x="0" y="0"/>
+          <a:ext cx="0" cy="0"/>
+          <a:chOff x="0" y="0"/>
+          <a:chExt cx="0" cy="0"/>
+        </a:xfrm>
+      </p:grpSpPr>
       <p:sp>
         <p:nvSpPr>
           <p:cNvPr id="2" name="Title 1"/>
@@ -4143,7 +4285,9 @@
               <a:t>└──────────────┘     └─────────────┘     └──────────────┘</a:t>
             </a:r>
           </a:p>
-          <a:p/>
+          <a:p>
+            <a:endParaRPr/>
+          </a:p>
           <a:p>
             <a:r>
               <a:t>Governance owners keep writing like they always have.</a:t>
@@ -4154,7 +4298,9 @@
               <a:t>But the output is structured, versioned, machine-readable.</a:t>
             </a:r>
           </a:p>
-          <a:p/>
+          <a:p>
+            <a:endParaRPr/>
+          </a:p>
           <a:p>
             <a:r>
               <a:t>→ Cross-railway interoperability (DB / SBB / ÖBB)</a:t>
@@ -4181,7 +4327,7 @@
 </file>
 
 <file path=ppt/slides/slide9.xml><?xml version="1.0" encoding="utf-8"?>
-<p:sld xmlns:a="http://schemas.openxmlformats.org/drawingml/2006/main" xmlns:p="http://schemas.openxmlformats.org/presentationml/2006/main" xmlns:r="http://schemas.openxmlformats.org/officeDocument/2006/relationships">
+<p:sld xmlns:a="http://schemas.openxmlformats.org/drawingml/2006/main" xmlns:r="http://schemas.openxmlformats.org/officeDocument/2006/relationships" xmlns:p="http://schemas.openxmlformats.org/presentationml/2006/main">
   <p:cSld>
     <p:spTree>
       <p:nvGrpSpPr>
@@ -4189,7 +4335,14 @@
         <p:cNvGrpSpPr/>
         <p:nvPr/>
       </p:nvGrpSpPr>
-      <p:grpSpPr/>
+      <p:grpSpPr>
+        <a:xfrm>
+          <a:off x="0" y="0"/>
+          <a:ext cx="0" cy="0"/>
+          <a:chOff x="0" y="0"/>
+          <a:chExt cx="0" cy="0"/>
+        </a:xfrm>
+      </p:grpSpPr>
       <p:sp>
         <p:nvSpPr>
           <p:cNvPr id="2" name="Title 1"/>
@@ -4206,6 +4359,7 @@
           <a:lstStyle/>
           <a:p>
             <a:r>
+              <a:rPr dirty="0"/>
               <a:t>OSCAL4Rail</a:t>
             </a:r>
           </a:p>
@@ -4227,28 +4381,37 @@
           <a:lstStyle/>
           <a:p>
             <a:r>
+              <a:rPr dirty="0"/>
               <a:t>Machine-readable governance for railways.</a:t>
             </a:r>
           </a:p>
-          <a:p/>
-          <a:p>
-            <a:r>
+          <a:p>
+            <a:endParaRPr dirty="0"/>
+          </a:p>
+          <a:p>
+            <a:r>
+              <a:rPr dirty="0"/>
               <a:t>Who makes the rules? Humans.</a:t>
             </a:r>
           </a:p>
           <a:p>
             <a:r>
+              <a:rPr dirty="0"/>
               <a:t>How we publish, version, and compare them?</a:t>
             </a:r>
           </a:p>
           <a:p>
             <a:r>
+              <a:rPr dirty="0"/>
               <a:t>That's a machine's job.</a:t>
             </a:r>
           </a:p>
-          <a:p/>
-          <a:p>
-            <a:r>
+          <a:p>
+            <a:endParaRPr dirty="0"/>
+          </a:p>
+          <a:p>
+            <a:r>
+              <a:rPr dirty="0"/>
               <a:t>Starting today.</a:t>
             </a:r>
           </a:p>
@@ -4578,18 +4741,6 @@
 </file>
 
 <file path=customXml/item1.xml><?xml version="1.0" encoding="utf-8"?>
-<p:properties xmlns:p="http://schemas.microsoft.com/office/2006/metadata/properties" xmlns:xsi="http://www.w3.org/2001/XMLSchema-instance" xmlns:pc="http://schemas.microsoft.com/office/infopath/2007/PartnerControls">
-  <documentManagement>
-    <Copyright xmlns="b106c448-c3d1-41cc-8fd9-3acb307364b4" xsi:nil="true"/>
-    <lcf76f155ced4ddcb4097134ff3c332f xmlns="b106c448-c3d1-41cc-8fd9-3acb307364b4">
-      <Terms xmlns="http://schemas.microsoft.com/office/infopath/2007/PartnerControls"/>
-    </lcf76f155ced4ddcb4097134ff3c332f>
-    <TaxCatchAll xmlns="b043894e-b4c8-44d0-9690-d7947297ac19" xsi:nil="true"/>
-  </documentManagement>
-</p:properties>
-</file>
-
-<file path=customXml/item2.xml><?xml version="1.0" encoding="utf-8"?>
 <ct:contentTypeSchema xmlns:ct="http://schemas.microsoft.com/office/2006/metadata/contentType" xmlns:ma="http://schemas.microsoft.com/office/2006/metadata/properties/metaAttributes" ct:_="" ma:_="" ma:contentTypeName="Dokument" ma:contentTypeID="0x010100C5895299445B8C4DB378BBB718B1F939" ma:contentTypeVersion="18" ma:contentTypeDescription="Ein neues Dokument erstellen." ma:contentTypeScope="" ma:versionID="ca18c32604eb9eb075bdd5b520f76d7f">
   <xsd:schema xmlns:xsd="http://www.w3.org/2001/XMLSchema" xmlns:xs="http://www.w3.org/2001/XMLSchema" xmlns:p="http://schemas.microsoft.com/office/2006/metadata/properties" xmlns:ns2="b106c448-c3d1-41cc-8fd9-3acb307364b4" xmlns:ns3="b043894e-b4c8-44d0-9690-d7947297ac19" targetNamespace="http://schemas.microsoft.com/office/2006/metadata/properties" ma:root="true" ma:fieldsID="0e0a0918b2fa3636e306fde1bc5c258b" ns2:_="" ns3:_="">
     <xsd:import namespace="b106c448-c3d1-41cc-8fd9-3acb307364b4"/>
@@ -4834,6 +4985,18 @@
 </ct:contentTypeSchema>
 </file>
 
+<file path=customXml/item2.xml><?xml version="1.0" encoding="utf-8"?>
+<p:properties xmlns:p="http://schemas.microsoft.com/office/2006/metadata/properties" xmlns:xsi="http://www.w3.org/2001/XMLSchema-instance" xmlns:pc="http://schemas.microsoft.com/office/infopath/2007/PartnerControls">
+  <documentManagement>
+    <Copyright xmlns="b106c448-c3d1-41cc-8fd9-3acb307364b4" xsi:nil="true"/>
+    <lcf76f155ced4ddcb4097134ff3c332f xmlns="b106c448-c3d1-41cc-8fd9-3acb307364b4">
+      <Terms xmlns="http://schemas.microsoft.com/office/infopath/2007/PartnerControls"/>
+    </lcf76f155ced4ddcb4097134ff3c332f>
+    <TaxCatchAll xmlns="b043894e-b4c8-44d0-9690-d7947297ac19" xsi:nil="true"/>
+  </documentManagement>
+</p:properties>
+</file>
+
 <file path=customXml/item3.xml><?xml version="1.0" encoding="utf-8"?>
 <?mso-contentType ?>
 <FormTemplates xmlns="http://schemas.microsoft.com/sharepoint/v3/contenttype/forms">
@@ -4844,23 +5007,6 @@
 </file>
 
 <file path=customXml/itemProps1.xml><?xml version="1.0" encoding="utf-8"?>
-<ds:datastoreItem xmlns:ds="http://schemas.openxmlformats.org/officeDocument/2006/customXml" ds:itemID="{B6D2420F-AFAE-4394-AC5D-D74FCC39CD53}">
-  <ds:schemaRefs>
-    <ds:schemaRef ds:uri="http://schemas.microsoft.com/office/infopath/2007/PartnerControls"/>
-    <ds:schemaRef ds:uri="http://www.w3.org/XML/1998/namespace"/>
-    <ds:schemaRef ds:uri="http://schemas.microsoft.com/office/2006/metadata/properties"/>
-    <ds:schemaRef ds:uri="http://purl.org/dc/elements/1.1/"/>
-    <ds:schemaRef ds:uri="http://schemas.openxmlformats.org/package/2006/metadata/core-properties"/>
-    <ds:schemaRef ds:uri="b043894e-b4c8-44d0-9690-d7947297ac19"/>
-    <ds:schemaRef ds:uri="http://schemas.microsoft.com/office/2006/documentManagement/types"/>
-    <ds:schemaRef ds:uri="b106c448-c3d1-41cc-8fd9-3acb307364b4"/>
-    <ds:schemaRef ds:uri="http://purl.org/dc/dcmitype/"/>
-    <ds:schemaRef ds:uri="http://purl.org/dc/terms/"/>
-  </ds:schemaRefs>
-</ds:datastoreItem>
-</file>
-
-<file path=customXml/itemProps2.xml><?xml version="1.0" encoding="utf-8"?>
 <ds:datastoreItem xmlns:ds="http://schemas.openxmlformats.org/officeDocument/2006/customXml" ds:itemID="{0BED3A9D-D1E4-45EA-8B49-CB6F60C2A98A}">
   <ds:schemaRefs>
     <ds:schemaRef ds:uri="http://schemas.microsoft.com/office/2006/metadata/contentType"/>
@@ -4879,6 +5025,23 @@
 </ds:datastoreItem>
 </file>
 
+<file path=customXml/itemProps2.xml><?xml version="1.0" encoding="utf-8"?>
+<ds:datastoreItem xmlns:ds="http://schemas.openxmlformats.org/officeDocument/2006/customXml" ds:itemID="{B6D2420F-AFAE-4394-AC5D-D74FCC39CD53}">
+  <ds:schemaRefs>
+    <ds:schemaRef ds:uri="http://schemas.microsoft.com/office/infopath/2007/PartnerControls"/>
+    <ds:schemaRef ds:uri="http://www.w3.org/XML/1998/namespace"/>
+    <ds:schemaRef ds:uri="http://schemas.microsoft.com/office/2006/metadata/properties"/>
+    <ds:schemaRef ds:uri="http://purl.org/dc/elements/1.1/"/>
+    <ds:schemaRef ds:uri="http://schemas.openxmlformats.org/package/2006/metadata/core-properties"/>
+    <ds:schemaRef ds:uri="b043894e-b4c8-44d0-9690-d7947297ac19"/>
+    <ds:schemaRef ds:uri="http://schemas.microsoft.com/office/2006/documentManagement/types"/>
+    <ds:schemaRef ds:uri="b106c448-c3d1-41cc-8fd9-3acb307364b4"/>
+    <ds:schemaRef ds:uri="http://purl.org/dc/dcmitype/"/>
+    <ds:schemaRef ds:uri="http://purl.org/dc/terms/"/>
+  </ds:schemaRefs>
+</ds:datastoreItem>
+</file>
+
 <file path=customXml/itemProps3.xml><?xml version="1.0" encoding="utf-8"?>
 <ds:datastoreItem xmlns:ds="http://schemas.openxmlformats.org/officeDocument/2006/customXml" ds:itemID="{47CF5FD6-43E2-4C9A-9372-C9D60EE1772B}">
   <ds:schemaRefs>

</xml_diff>

<commit_message>
docs: update whomakestherules presentation
</commit_message>
<xml_diff>
--- a/whomakestherules/A38_H4R2026_Ch7.pptx
+++ b/whomakestherules/A38_H4R2026_Ch7.pptx
@@ -3452,6 +3452,7 @@
           <a:lstStyle/>
           <a:p>
             <a:r>
+              <a:rPr dirty="0"/>
               <a:t>Who Makes the Rules?</a:t>
             </a:r>
           </a:p>
@@ -3680,6 +3681,7 @@
           <a:lstStyle/>
           <a:p>
             <a:r>
+              <a:rPr dirty="0"/>
               <a:t>The Paradigm Shift</a:t>
             </a:r>
           </a:p>
@@ -3695,58 +3697,274 @@
             <p:ph idx="1"/>
           </p:nvPr>
         </p:nvSpPr>
-        <p:spPr/>
-        <p:txBody>
-          <a:bodyPr/>
-          <a:lstStyle/>
-          <a:p>
-            <a:r>
+        <p:spPr>
+          <a:xfrm>
+            <a:off x="689919" y="1590847"/>
+            <a:ext cx="10515600" cy="2476211"/>
+          </a:xfrm>
+        </p:spPr>
+        <p:txBody>
+          <a:bodyPr>
+            <a:normAutofit fontScale="85000" lnSpcReduction="20000"/>
+          </a:bodyPr>
+          <a:lstStyle/>
+          <a:p>
+            <a:pPr marL="0" indent="0">
+              <a:buNone/>
+            </a:pPr>
+            <a:r>
+              <a:rPr dirty="0">
+                <a:solidFill>
+                  <a:srgbClr val="FF0000"/>
+                </a:solidFill>
+              </a:rPr>
               <a:t>TODAY:</a:t>
             </a:r>
           </a:p>
           <a:p>
-            <a:r>
-              <a:t>  Word → PDF → humans extract what applies</a:t>
-            </a:r>
-          </a:p>
-          <a:p>
-            <a:endParaRPr/>
-          </a:p>
-          <a:p>
-            <a:r>
+            <a:pPr marL="0" indent="0">
+              <a:buNone/>
+            </a:pPr>
+            <a:r>
+              <a:rPr dirty="0"/>
+              <a:t>Word → PDF → humans extract</a:t>
+            </a:r>
+            <a:r>
+              <a:rPr lang="de-DE" dirty="0"/>
+              <a:t> and </a:t>
+            </a:r>
+            <a:r>
+              <a:rPr lang="de-DE" dirty="0" err="1"/>
+              <a:t>interpret</a:t>
+            </a:r>
+            <a:r>
+              <a:rPr dirty="0"/>
+              <a:t> what applies</a:t>
+            </a:r>
+          </a:p>
+          <a:p>
+            <a:endParaRPr dirty="0"/>
+          </a:p>
+          <a:p>
+            <a:pPr marL="0" indent="0">
+              <a:buNone/>
+            </a:pPr>
+            <a:r>
+              <a:rPr dirty="0">
+                <a:solidFill>
+                  <a:srgbClr val="FF0000"/>
+                </a:solidFill>
+              </a:rPr>
               <a:t>OUR PROPOSAL:</a:t>
             </a:r>
           </a:p>
           <a:p>
             <a:r>
-              <a:t>  Machine-readable FIRST, PDF second.</a:t>
-            </a:r>
-          </a:p>
-          <a:p>
-            <a:r>
-              <a:t>  The canonical source is structured data.</a:t>
-            </a:r>
-          </a:p>
-          <a:p>
-            <a:r>
-              <a:t>  The PDF is a generated view.</a:t>
-            </a:r>
-          </a:p>
-          <a:p>
-            <a:endParaRPr/>
-          </a:p>
-          <a:p>
-            <a:r>
-              <a:t>NIST does it (OSCAL). BSI adopted it.</a:t>
-            </a:r>
-          </a:p>
-          <a:p>
-            <a:r>
+              <a:rPr dirty="0"/>
+              <a:t>Machine-readable FIRST, PDF</a:t>
+            </a:r>
+            <a:r>
+              <a:rPr lang="de-DE" dirty="0"/>
+              <a:t>/</a:t>
+            </a:r>
+            <a:r>
+              <a:rPr lang="de-DE" dirty="0" err="1"/>
+              <a:t>other</a:t>
+            </a:r>
+            <a:r>
+              <a:rPr dirty="0"/>
+              <a:t> second.</a:t>
+            </a:r>
+          </a:p>
+          <a:p>
+            <a:r>
+              <a:rPr dirty="0"/>
+              <a:t>The canonical source is structured data</a:t>
+            </a:r>
+            <a:r>
+              <a:rPr lang="de-DE" dirty="0"/>
+              <a:t> als </a:t>
+            </a:r>
+            <a:r>
+              <a:rPr lang="de-DE" dirty="0" err="1"/>
+              <a:t>single</a:t>
+            </a:r>
+            <a:r>
+              <a:rPr lang="de-DE" dirty="0"/>
+              <a:t> </a:t>
+            </a:r>
+            <a:r>
+              <a:rPr lang="de-DE" dirty="0" err="1"/>
+              <a:t>point</a:t>
+            </a:r>
+            <a:r>
+              <a:rPr lang="de-DE" dirty="0"/>
+              <a:t> </a:t>
+            </a:r>
+            <a:r>
+              <a:rPr lang="de-DE" dirty="0" err="1"/>
+              <a:t>of</a:t>
+            </a:r>
+            <a:r>
+              <a:rPr lang="de-DE" dirty="0"/>
+              <a:t> </a:t>
+            </a:r>
+            <a:r>
+              <a:rPr lang="de-DE" dirty="0" err="1"/>
+              <a:t>truth</a:t>
+            </a:r>
+            <a:endParaRPr dirty="0"/>
+          </a:p>
+          <a:p>
+            <a:pPr marL="0" indent="0">
+              <a:buNone/>
+            </a:pPr>
+            <a:endParaRPr dirty="0"/>
+          </a:p>
+          <a:p>
+            <a:pPr marL="0" indent="0">
+              <a:buNone/>
+            </a:pPr>
+            <a:endParaRPr lang="en-GB" dirty="0"/>
+          </a:p>
+        </p:txBody>
+      </p:sp>
+      <p:pic>
+        <p:nvPicPr>
+          <p:cNvPr id="5" name="Picture 4">
+            <a:extLst>
+              <a:ext uri="{FF2B5EF4-FFF2-40B4-BE49-F238E27FC236}">
+                <a16:creationId xmlns:a16="http://schemas.microsoft.com/office/drawing/2014/main" id="{0AF1082A-27B6-30DC-9FE7-DD832ED10D86}"/>
+              </a:ext>
+            </a:extLst>
+          </p:cNvPr>
+          <p:cNvPicPr>
+            <a:picLocks noChangeAspect="1"/>
+          </p:cNvPicPr>
+          <p:nvPr/>
+        </p:nvPicPr>
+        <p:blipFill>
+          <a:blip r:embed="rId2"/>
+          <a:stretch>
+            <a:fillRect/>
+          </a:stretch>
+        </p:blipFill>
+        <p:spPr>
+          <a:xfrm>
+            <a:off x="436418" y="4506777"/>
+            <a:ext cx="2859228" cy="1012540"/>
+          </a:xfrm>
+          <a:prstGeom prst="rect">
+            <a:avLst/>
+          </a:prstGeom>
+        </p:spPr>
+      </p:pic>
+      <p:pic>
+        <p:nvPicPr>
+          <p:cNvPr id="6" name="Picture 5" descr="BSI - IT-Grundschutz">
+            <a:extLst>
+              <a:ext uri="{FF2B5EF4-FFF2-40B4-BE49-F238E27FC236}">
+                <a16:creationId xmlns:a16="http://schemas.microsoft.com/office/drawing/2014/main" id="{6E4CCAA5-719B-E2B5-0EE6-2842787744AF}"/>
+              </a:ext>
+            </a:extLst>
+          </p:cNvPr>
+          <p:cNvPicPr>
+            <a:picLocks noChangeAspect="1"/>
+          </p:cNvPicPr>
+          <p:nvPr/>
+        </p:nvPicPr>
+        <p:blipFill>
+          <a:blip r:embed="rId3"/>
+          <a:stretch>
+            <a:fillRect/>
+          </a:stretch>
+        </p:blipFill>
+        <p:spPr>
+          <a:xfrm>
+            <a:off x="6905272" y="4436773"/>
+            <a:ext cx="1624822" cy="977535"/>
+          </a:xfrm>
+          <a:prstGeom prst="rect">
+            <a:avLst/>
+          </a:prstGeom>
+        </p:spPr>
+      </p:pic>
+      <p:sp>
+        <p:nvSpPr>
+          <p:cNvPr id="4" name="TextBox 3">
+            <a:extLst>
+              <a:ext uri="{FF2B5EF4-FFF2-40B4-BE49-F238E27FC236}">
+                <a16:creationId xmlns:a16="http://schemas.microsoft.com/office/drawing/2014/main" id="{DE226D47-646A-89B6-0FB8-F581EAA66638}"/>
+              </a:ext>
+            </a:extLst>
+          </p:cNvPr>
+          <p:cNvSpPr txBox="1"/>
+          <p:nvPr/>
+        </p:nvSpPr>
+        <p:spPr>
+          <a:xfrm>
+            <a:off x="1274618" y="4673030"/>
+            <a:ext cx="10079182" cy="1938992"/>
+          </a:xfrm>
+          <a:prstGeom prst="rect">
+            <a:avLst/>
+          </a:prstGeom>
+          <a:noFill/>
+        </p:spPr>
+        <p:txBody>
+          <a:bodyPr wrap="square" rtlCol="0">
+            <a:spAutoFit/>
+          </a:bodyPr>
+          <a:lstStyle/>
+          <a:p>
+            <a:r>
+              <a:rPr lang="en-GB" sz="4000" dirty="0"/>
+              <a:t>          	 does it (OSCAL).                  adopted it.</a:t>
+            </a:r>
+          </a:p>
+          <a:p>
+            <a:endParaRPr lang="en-GB" sz="4000" dirty="0"/>
+          </a:p>
+          <a:p>
+            <a:pPr algn="ctr"/>
+            <a:r>
+              <a:rPr lang="en-GB" sz="4000" dirty="0"/>
               <a:t>We bring it to rail: OSCAL4Rail.</a:t>
             </a:r>
-          </a:p>
-        </p:txBody>
-      </p:sp>
+            <a:endParaRPr lang="de-DE" sz="4000" dirty="0"/>
+          </a:p>
+        </p:txBody>
+      </p:sp>
+      <p:pic>
+        <p:nvPicPr>
+          <p:cNvPr id="7" name="Picture 6" descr="UIC and its members begin work on the OpenRail Foundation ...">
+            <a:extLst>
+              <a:ext uri="{FF2B5EF4-FFF2-40B4-BE49-F238E27FC236}">
+                <a16:creationId xmlns:a16="http://schemas.microsoft.com/office/drawing/2014/main" id="{A13D5640-F600-AA2F-159A-C28A748D1C48}"/>
+              </a:ext>
+            </a:extLst>
+          </p:cNvPr>
+          <p:cNvPicPr>
+            <a:picLocks noChangeAspect="1"/>
+          </p:cNvPicPr>
+          <p:nvPr/>
+        </p:nvPicPr>
+        <p:blipFill>
+          <a:blip r:embed="rId4"/>
+          <a:stretch>
+            <a:fillRect/>
+          </a:stretch>
+        </p:blipFill>
+        <p:spPr>
+          <a:xfrm>
+            <a:off x="1526059" y="5672222"/>
+            <a:ext cx="1371600" cy="939800"/>
+          </a:xfrm>
+          <a:prstGeom prst="rect">
+            <a:avLst/>
+          </a:prstGeom>
+        </p:spPr>
+      </p:pic>
     </p:spTree>
   </p:cSld>
   <p:clrMapOvr>
@@ -3788,6 +4006,27 @@
           <a:lstStyle/>
           <a:p>
             <a:r>
+              <a:rPr lang="de-DE" dirty="0"/>
+              <a:t>Idea </a:t>
+            </a:r>
+            <a:r>
+              <a:rPr lang="de-DE" dirty="0" err="1"/>
+              <a:t>for</a:t>
+            </a:r>
+            <a:r>
+              <a:rPr lang="de-DE" dirty="0"/>
+              <a:t> </a:t>
+            </a:r>
+            <a:r>
+              <a:rPr lang="de-DE" dirty="0" err="1"/>
+              <a:t>Standardization</a:t>
+            </a:r>
+            <a:r>
+              <a:rPr lang="de-DE" dirty="0"/>
+              <a:t>: </a:t>
+            </a:r>
+            <a:r>
+              <a:rPr dirty="0"/>
               <a:t>OSCAL4Rail</a:t>
             </a:r>
           </a:p>
@@ -3805,63 +4044,260 @@
         </p:nvSpPr>
         <p:spPr/>
         <p:txBody>
-          <a:bodyPr/>
-          <a:lstStyle/>
-          <a:p>
-            <a:r>
+          <a:bodyPr>
+            <a:normAutofit/>
+          </a:bodyPr>
+          <a:lstStyle/>
+          <a:p>
+            <a:pPr marL="0" indent="0">
+              <a:buNone/>
+            </a:pPr>
+            <a:r>
+              <a:rPr dirty="0"/>
               <a:t>Lightweight profile of NIST OSCAL for railway regulations</a:t>
             </a:r>
           </a:p>
           <a:p>
-            <a:endParaRPr/>
-          </a:p>
-          <a:p>
-            <a:r>
-              <a:t>Catalog → Groups → Controls</a:t>
-            </a:r>
-          </a:p>
-          <a:p>
-            <a:r>
-              <a:t>  │         │        └─ One rule (verbatim text)</a:t>
-            </a:r>
-          </a:p>
-          <a:p>
-            <a:r>
-              <a:t>  │         └─ One chapter</a:t>
-            </a:r>
-          </a:p>
-          <a:p>
-            <a:r>
-              <a:t>  └─ One regulation</a:t>
-            </a:r>
-          </a:p>
-          <a:p>
-            <a:endParaRPr/>
-          </a:p>
-          <a:p>
-            <a:r>
-              <a:t>Key features:</a:t>
-            </a:r>
-          </a:p>
-          <a:p>
-            <a:r>
-              <a:t>• Validated against official NIST JSON Schema</a:t>
-            </a:r>
-          </a:p>
-          <a:p>
-            <a:r>
-              <a:t>• Verbatim rule text (no interpretation)</a:t>
-            </a:r>
-          </a:p>
-          <a:p>
-            <a:r>
-              <a:t>• Applicability matrix (channel × transport mode)</a:t>
-            </a:r>
-          </a:p>
-          <a:p>
-            <a:r>
-              <a:t>• Versioned in Git → changelog for free</a:t>
-            </a:r>
+            <a:endParaRPr dirty="0"/>
+          </a:p>
+          <a:p>
+            <a:pPr marL="0" indent="0">
+              <a:buNone/>
+            </a:pPr>
+            <a:r>
+              <a:rPr dirty="0"/>
+              <a:t>Catalog </a:t>
+            </a:r>
+            <a:r>
+              <a:rPr lang="de-DE" dirty="0"/>
+              <a:t>		</a:t>
+            </a:r>
+            <a:r>
+              <a:rPr dirty="0"/>
+              <a:t> </a:t>
+            </a:r>
+            <a:r>
+              <a:rPr lang="de-DE" dirty="0"/>
+              <a:t>	</a:t>
+            </a:r>
+            <a:r>
+              <a:rPr dirty="0"/>
+              <a:t>Groups </a:t>
+            </a:r>
+            <a:r>
+              <a:rPr lang="de-DE" dirty="0"/>
+              <a:t>				</a:t>
+            </a:r>
+            <a:r>
+              <a:rPr dirty="0"/>
+              <a:t>Controls</a:t>
+            </a:r>
+          </a:p>
+          <a:p>
+            <a:pPr marL="0" indent="0">
+              <a:buNone/>
+            </a:pPr>
+            <a:endParaRPr lang="de-DE" dirty="0"/>
+          </a:p>
+          <a:p>
+            <a:pPr marL="0" indent="0">
+              <a:buNone/>
+            </a:pPr>
+            <a:r>
+              <a:rPr dirty="0"/>
+              <a:t>                  </a:t>
+            </a:r>
+            <a:r>
+              <a:rPr lang="de-DE" dirty="0"/>
+              <a:t>							</a:t>
+            </a:r>
+            <a:r>
+              <a:rPr dirty="0"/>
+              <a:t>One rule (verbatim text)</a:t>
+            </a:r>
+          </a:p>
+          <a:p>
+            <a:pPr marL="0" indent="0">
+              <a:buNone/>
+            </a:pPr>
+            <a:r>
+              <a:rPr dirty="0"/>
+              <a:t>          </a:t>
+            </a:r>
+            <a:r>
+              <a:rPr lang="de-DE" dirty="0"/>
+              <a:t>	</a:t>
+            </a:r>
+            <a:r>
+              <a:rPr dirty="0"/>
+              <a:t> </a:t>
+            </a:r>
+            <a:r>
+              <a:rPr lang="de-DE" dirty="0"/>
+              <a:t>				</a:t>
+            </a:r>
+            <a:r>
+              <a:rPr dirty="0"/>
+              <a:t>One chapter</a:t>
+            </a:r>
+          </a:p>
+          <a:p>
+            <a:pPr marL="0" indent="0">
+              <a:buNone/>
+            </a:pPr>
+            <a:r>
+              <a:rPr dirty="0"/>
+              <a:t> </a:t>
+            </a:r>
+            <a:r>
+              <a:rPr lang="de-DE" dirty="0"/>
+              <a:t>		</a:t>
+            </a:r>
+            <a:r>
+              <a:rPr dirty="0"/>
+              <a:t>One regulation</a:t>
+            </a:r>
+          </a:p>
+          <a:p>
+            <a:endParaRPr dirty="0"/>
+          </a:p>
+        </p:txBody>
+      </p:sp>
+      <p:sp>
+        <p:nvSpPr>
+          <p:cNvPr id="6" name="Bent Up Arrow 5">
+            <a:extLst>
+              <a:ext uri="{FF2B5EF4-FFF2-40B4-BE49-F238E27FC236}">
+                <a16:creationId xmlns:a16="http://schemas.microsoft.com/office/drawing/2014/main" id="{C9A8700C-4511-6B02-6C20-FEE56495E247}"/>
+              </a:ext>
+            </a:extLst>
+          </p:cNvPr>
+          <p:cNvSpPr/>
+          <p:nvPr/>
+        </p:nvSpPr>
+        <p:spPr>
+          <a:xfrm rot="5400000">
+            <a:off x="1072978" y="4816841"/>
+            <a:ext cx="951471" cy="914400"/>
+          </a:xfrm>
+          <a:prstGeom prst="bentUpArrow">
+            <a:avLst/>
+          </a:prstGeom>
+        </p:spPr>
+        <p:style>
+          <a:lnRef idx="2">
+            <a:schemeClr val="accent1">
+              <a:shade val="15000"/>
+            </a:schemeClr>
+          </a:lnRef>
+          <a:fillRef idx="1">
+            <a:schemeClr val="accent1"/>
+          </a:fillRef>
+          <a:effectRef idx="0">
+            <a:schemeClr val="accent1"/>
+          </a:effectRef>
+          <a:fontRef idx="minor">
+            <a:schemeClr val="lt1"/>
+          </a:fontRef>
+        </p:style>
+        <p:txBody>
+          <a:bodyPr rtlCol="0" anchor="ctr"/>
+          <a:lstStyle/>
+          <a:p>
+            <a:pPr algn="ctr"/>
+            <a:endParaRPr lang="de-DE" dirty="0"/>
+          </a:p>
+        </p:txBody>
+      </p:sp>
+      <p:sp>
+        <p:nvSpPr>
+          <p:cNvPr id="7" name="Bent Up Arrow 6">
+            <a:extLst>
+              <a:ext uri="{FF2B5EF4-FFF2-40B4-BE49-F238E27FC236}">
+                <a16:creationId xmlns:a16="http://schemas.microsoft.com/office/drawing/2014/main" id="{7B313AC3-B649-BEE5-6F2B-B5EDD2283236}"/>
+              </a:ext>
+            </a:extLst>
+          </p:cNvPr>
+          <p:cNvSpPr/>
+          <p:nvPr/>
+        </p:nvSpPr>
+        <p:spPr>
+          <a:xfrm rot="5400000">
+            <a:off x="4333100" y="4103063"/>
+            <a:ext cx="951472" cy="1089454"/>
+          </a:xfrm>
+          <a:prstGeom prst="bentUpArrow">
+            <a:avLst/>
+          </a:prstGeom>
+        </p:spPr>
+        <p:style>
+          <a:lnRef idx="2">
+            <a:schemeClr val="accent1">
+              <a:shade val="15000"/>
+            </a:schemeClr>
+          </a:lnRef>
+          <a:fillRef idx="1">
+            <a:schemeClr val="accent1"/>
+          </a:fillRef>
+          <a:effectRef idx="0">
+            <a:schemeClr val="accent1"/>
+          </a:effectRef>
+          <a:fontRef idx="minor">
+            <a:schemeClr val="lt1"/>
+          </a:fontRef>
+        </p:style>
+        <p:txBody>
+          <a:bodyPr rtlCol="0" anchor="ctr"/>
+          <a:lstStyle/>
+          <a:p>
+            <a:pPr algn="ctr"/>
+            <a:endParaRPr lang="de-DE" dirty="0"/>
+          </a:p>
+        </p:txBody>
+      </p:sp>
+      <p:sp>
+        <p:nvSpPr>
+          <p:cNvPr id="8" name="Bent Up Arrow 7">
+            <a:extLst>
+              <a:ext uri="{FF2B5EF4-FFF2-40B4-BE49-F238E27FC236}">
+                <a16:creationId xmlns:a16="http://schemas.microsoft.com/office/drawing/2014/main" id="{C6C33A61-1A79-E04A-E3DB-152CB9AA07C4}"/>
+              </a:ext>
+            </a:extLst>
+          </p:cNvPr>
+          <p:cNvSpPr/>
+          <p:nvPr/>
+        </p:nvSpPr>
+        <p:spPr>
+          <a:xfrm rot="5400000">
+            <a:off x="7592651" y="3667146"/>
+            <a:ext cx="432607" cy="668295"/>
+          </a:xfrm>
+          <a:prstGeom prst="bentUpArrow">
+            <a:avLst/>
+          </a:prstGeom>
+        </p:spPr>
+        <p:style>
+          <a:lnRef idx="2">
+            <a:schemeClr val="accent1">
+              <a:shade val="15000"/>
+            </a:schemeClr>
+          </a:lnRef>
+          <a:fillRef idx="1">
+            <a:schemeClr val="accent1"/>
+          </a:fillRef>
+          <a:effectRef idx="0">
+            <a:schemeClr val="accent1"/>
+          </a:effectRef>
+          <a:fontRef idx="minor">
+            <a:schemeClr val="lt1"/>
+          </a:fontRef>
+        </p:style>
+        <p:txBody>
+          <a:bodyPr rtlCol="0" anchor="ctr"/>
+          <a:lstStyle/>
+          <a:p>
+            <a:pPr algn="ctr"/>
+            <a:endParaRPr lang="de-DE" dirty="0"/>
           </a:p>
         </p:txBody>
       </p:sp>
@@ -3906,6 +4342,7 @@
           <a:lstStyle/>
           <a:p>
             <a:r>
+              <a:rPr dirty="0"/>
               <a:t>Proof of Concept: BS-KI (Switzerland)</a:t>
             </a:r>
           </a:p>
@@ -3923,56 +4360,90 @@
         </p:nvSpPr>
         <p:spPr/>
         <p:txBody>
-          <a:bodyPr/>
-          <a:lstStyle/>
-          <a:p>
-            <a:r>
-              <a:t>Branchenstandard Kundeninformation</a:t>
-            </a:r>
-          </a:p>
-          <a:p>
-            <a:r>
+          <a:bodyPr>
+            <a:normAutofit fontScale="85000" lnSpcReduction="20000"/>
+          </a:bodyPr>
+          <a:lstStyle/>
+          <a:p>
+            <a:pPr marL="0" indent="0">
+              <a:buNone/>
+            </a:pPr>
+            <a:r>
+              <a:rPr dirty="0" err="1"/>
+              <a:t>Branchenstandard</a:t>
+            </a:r>
+            <a:r>
+              <a:rPr dirty="0"/>
+              <a:t> </a:t>
+            </a:r>
+            <a:r>
+              <a:rPr dirty="0" err="1"/>
+              <a:t>Kundeninformation</a:t>
+            </a:r>
+            <a:endParaRPr dirty="0"/>
+          </a:p>
+          <a:p>
+            <a:r>
+              <a:rPr dirty="0"/>
               <a:t>44 rules × 6 channels × 4 transport modes</a:t>
             </a:r>
-          </a:p>
-          <a:p>
-            <a:endParaRPr/>
-          </a:p>
-          <a:p>
-            <a:r>
+            <a:endParaRPr lang="de-DE" dirty="0"/>
+          </a:p>
+          <a:p>
+            <a:endParaRPr dirty="0"/>
+          </a:p>
+          <a:p>
+            <a:pPr marL="0" indent="0">
+              <a:buNone/>
+            </a:pPr>
+            <a:r>
+              <a:rPr dirty="0"/>
               <a:t>What we did:</a:t>
             </a:r>
-          </a:p>
-          <a:p>
-            <a:r>
-              <a:t>• Excel matrix → parsed deterministically</a:t>
-            </a:r>
-          </a:p>
-          <a:p>
-            <a:r>
-              <a:t>• PDF (64 pages) → chapter-level text extraction</a:t>
-            </a:r>
-          </a:p>
-          <a:p>
-            <a:r>
-              <a:t>• Combined → one OSCAL Catalog YAML</a:t>
-            </a:r>
-          </a:p>
-          <a:p>
-            <a:r>
-              <a:t>• Validated against NIST JSON Schema ✅</a:t>
-            </a:r>
-          </a:p>
-          <a:p>
-            <a:endParaRPr/>
-          </a:p>
-          <a:p>
-            <a:r>
+            <a:endParaRPr lang="de-DE" dirty="0"/>
+          </a:p>
+          <a:p>
+            <a:r>
+              <a:rPr dirty="0"/>
+              <a:t>Excel matrix → parsed deterministically</a:t>
+            </a:r>
+          </a:p>
+          <a:p>
+            <a:r>
+              <a:rPr dirty="0"/>
+              <a:t>PDF (64 pages) → chapter-level text extraction</a:t>
+            </a:r>
+          </a:p>
+          <a:p>
+            <a:r>
+              <a:rPr dirty="0"/>
+              <a:t>Combined → one OSCAL Catalog YAML</a:t>
+            </a:r>
+          </a:p>
+          <a:p>
+            <a:r>
+              <a:rPr dirty="0"/>
+              <a:t>Validated against NIST JSON Schema ✅</a:t>
+            </a:r>
+          </a:p>
+          <a:p>
+            <a:endParaRPr dirty="0"/>
+          </a:p>
+          <a:p>
+            <a:pPr marL="0" indent="0">
+              <a:buNone/>
+            </a:pPr>
+            <a:r>
+              <a:rPr dirty="0"/>
               <a:t>What changed between 2024 and 2025?</a:t>
             </a:r>
           </a:p>
           <a:p>
-            <a:r>
+            <a:pPr marL="0" indent="0">
+              <a:buNone/>
+            </a:pPr>
+            <a:r>
+              <a:rPr dirty="0"/>
               <a:t>→ git diff. Done.</a:t>
             </a:r>
           </a:p>
@@ -4019,6 +4490,7 @@
           <a:lstStyle/>
           <a:p>
             <a:r>
+              <a:rPr dirty="0"/>
               <a:t>Versioning &amp; History</a:t>
             </a:r>
           </a:p>
@@ -4036,47 +4508,113 @@
         </p:nvSpPr>
         <p:spPr/>
         <p:txBody>
-          <a:bodyPr/>
-          <a:lstStyle/>
-          <a:p>
-            <a:r>
-              <a:t>Because it's in Git:</a:t>
-            </a:r>
-          </a:p>
-          <a:p>
-            <a:endParaRPr/>
-          </a:p>
-          <a:p>
-            <a:r>
-              <a:t>• Full version history of every rule</a:t>
-            </a:r>
-          </a:p>
-          <a:p>
-            <a:r>
-              <a:t>• Diff: what changed, when, by whom</a:t>
-            </a:r>
-          </a:p>
-          <a:p>
-            <a:r>
-              <a:t>• Rollback: revert to any previous state</a:t>
-            </a:r>
-          </a:p>
-          <a:p>
-            <a:r>
-              <a:t>• Audit trail: who approved what</a:t>
-            </a:r>
-          </a:p>
-          <a:p>
-            <a:endParaRPr/>
-          </a:p>
-          <a:p>
-            <a:r>
+          <a:bodyPr>
+            <a:normAutofit lnSpcReduction="10000"/>
+          </a:bodyPr>
+          <a:lstStyle/>
+          <a:p>
+            <a:r>
+              <a:rPr dirty="0"/>
+              <a:t>Because it's in Git</a:t>
+            </a:r>
+            <a:r>
+              <a:rPr lang="de-DE" dirty="0"/>
+              <a:t> and </a:t>
+            </a:r>
+            <a:r>
+              <a:rPr lang="de-DE" dirty="0" err="1"/>
+              <a:t>Json</a:t>
+            </a:r>
+            <a:r>
+              <a:rPr lang="de-DE" dirty="0"/>
+              <a:t>/Schema</a:t>
+            </a:r>
+            <a:r>
+              <a:rPr dirty="0"/>
+              <a:t>:</a:t>
+            </a:r>
+          </a:p>
+          <a:p>
+            <a:endParaRPr dirty="0"/>
+          </a:p>
+          <a:p>
+            <a:r>
+              <a:rPr dirty="0"/>
+              <a:t>Full version history of every rule</a:t>
+            </a:r>
+          </a:p>
+          <a:p>
+            <a:r>
+              <a:rPr dirty="0"/>
+              <a:t>Diff: what changed, when, by whom</a:t>
+            </a:r>
+          </a:p>
+          <a:p>
+            <a:r>
+              <a:rPr dirty="0"/>
+              <a:t>Rollback: revert to any previous state</a:t>
+            </a:r>
+          </a:p>
+          <a:p>
+            <a:r>
+              <a:rPr dirty="0"/>
+              <a:t>Audit trail: who approved what</a:t>
+            </a:r>
+          </a:p>
+          <a:p>
+            <a:endParaRPr dirty="0"/>
+          </a:p>
+          <a:p>
+            <a:pPr marL="0" indent="0">
+              <a:buNone/>
+            </a:pPr>
+            <a:r>
+              <a:rPr dirty="0"/>
               <a:t>No more: "Which version is current?"</a:t>
             </a:r>
           </a:p>
           <a:p>
-            <a:r>
+            <a:pPr marL="0" indent="0">
+              <a:buNone/>
+            </a:pPr>
+            <a:r>
+              <a:rPr dirty="0"/>
               <a:t>No more: "What exactly changed in §4.2?"</a:t>
+            </a:r>
+          </a:p>
+        </p:txBody>
+      </p:sp>
+      <p:sp>
+        <p:nvSpPr>
+          <p:cNvPr id="4" name="TextBox 3">
+            <a:extLst>
+              <a:ext uri="{FF2B5EF4-FFF2-40B4-BE49-F238E27FC236}">
+                <a16:creationId xmlns:a16="http://schemas.microsoft.com/office/drawing/2014/main" id="{3B27477D-692D-FE66-949F-8A575977F1B0}"/>
+              </a:ext>
+            </a:extLst>
+          </p:cNvPr>
+          <p:cNvSpPr txBox="1"/>
+          <p:nvPr/>
+        </p:nvSpPr>
+        <p:spPr>
+          <a:xfrm>
+            <a:off x="8530936" y="4073236"/>
+            <a:ext cx="1662546" cy="1477328"/>
+          </a:xfrm>
+          <a:prstGeom prst="rect">
+            <a:avLst/>
+          </a:prstGeom>
+          <a:noFill/>
+        </p:spPr>
+        <p:txBody>
+          <a:bodyPr wrap="square" rtlCol="0">
+            <a:spAutoFit/>
+          </a:bodyPr>
+          <a:lstStyle/>
+          <a:p>
+            <a:r>
+              <a:rPr lang="de-DE" dirty="0"/>
+              <a:t>Mensch mit Fragezeichen auf Kopf und Paragrafenzeichen</a:t>
             </a:r>
           </a:p>
         </p:txBody>
@@ -4137,65 +4675,241 @@
             <p:ph idx="1"/>
           </p:nvPr>
         </p:nvSpPr>
-        <p:spPr/>
-        <p:txBody>
-          <a:bodyPr/>
-          <a:lstStyle/>
-          <a:p>
-            <a:r>
+        <p:spPr>
+          <a:xfrm>
+            <a:off x="838200" y="1825625"/>
+            <a:ext cx="10515600" cy="3611348"/>
+          </a:xfrm>
+        </p:spPr>
+        <p:txBody>
+          <a:bodyPr>
+            <a:normAutofit fontScale="77500" lnSpcReduction="20000"/>
+          </a:bodyPr>
+          <a:lstStyle/>
+          <a:p>
+            <a:pPr marL="0" indent="0">
+              <a:buNone/>
+            </a:pPr>
+            <a:r>
+              <a:rPr dirty="0"/>
               <a:t>1. Start with IT/ITS regulations</a:t>
             </a:r>
-          </a:p>
-          <a:p>
-            <a:r>
-              <a:t>   (already structured, digital-native)</a:t>
-            </a:r>
-          </a:p>
-          <a:p>
-            <a:endParaRPr/>
-          </a:p>
-          <a:p>
-            <a:r>
+            <a:r>
+              <a:rPr lang="de-DE" dirty="0"/>
+              <a:t> </a:t>
+            </a:r>
+            <a:r>
+              <a:rPr dirty="0"/>
+              <a:t>(already structured, digital-native)</a:t>
+            </a:r>
+            <a:endParaRPr lang="de-DE" dirty="0"/>
+          </a:p>
+          <a:p>
+            <a:pPr marL="0" indent="0">
+              <a:buNone/>
+            </a:pPr>
+            <a:r>
+              <a:rPr lang="de-DE" dirty="0"/>
+              <a:t>	- </a:t>
+            </a:r>
+            <a:r>
+              <a:rPr lang="de-DE" dirty="0" err="1"/>
+              <a:t>Verify</a:t>
+            </a:r>
+            <a:r>
+              <a:rPr lang="de-DE" dirty="0"/>
+              <a:t> </a:t>
+            </a:r>
+            <a:r>
+              <a:rPr lang="de-DE" dirty="0" err="1"/>
+              <a:t>automated</a:t>
+            </a:r>
+            <a:r>
+              <a:rPr lang="de-DE" dirty="0"/>
+              <a:t> </a:t>
+            </a:r>
+            <a:r>
+              <a:rPr lang="de-DE" dirty="0" err="1"/>
+              <a:t>creation</a:t>
+            </a:r>
+            <a:r>
+              <a:rPr lang="de-DE" dirty="0"/>
+              <a:t> </a:t>
+            </a:r>
+            <a:r>
+              <a:rPr lang="de-DE" dirty="0" err="1"/>
+              <a:t>of</a:t>
+            </a:r>
+            <a:r>
+              <a:rPr lang="de-DE" dirty="0"/>
+              <a:t> </a:t>
+            </a:r>
+            <a:r>
+              <a:rPr lang="de-DE" dirty="0" err="1"/>
+              <a:t>schemata</a:t>
+            </a:r>
+            <a:r>
+              <a:rPr lang="de-DE" dirty="0"/>
+              <a:t> </a:t>
+            </a:r>
+            <a:r>
+              <a:rPr lang="de-DE" dirty="0" err="1"/>
+              <a:t>with</a:t>
+            </a:r>
+            <a:r>
+              <a:rPr lang="de-DE" dirty="0"/>
+              <a:t> </a:t>
+            </a:r>
+            <a:r>
+              <a:rPr lang="de-DE" dirty="0" err="1"/>
+              <a:t>governance</a:t>
+            </a:r>
+            <a:r>
+              <a:rPr lang="de-DE" dirty="0"/>
+              <a:t> </a:t>
+            </a:r>
+            <a:r>
+              <a:rPr lang="de-DE" dirty="0" err="1"/>
+              <a:t>owners</a:t>
+            </a:r>
+            <a:endParaRPr dirty="0"/>
+          </a:p>
+          <a:p>
+            <a:endParaRPr dirty="0"/>
+          </a:p>
+          <a:p>
+            <a:pPr marL="0" indent="0">
+              <a:buNone/>
+            </a:pPr>
+            <a:r>
+              <a:rPr dirty="0"/>
               <a:t>2. Web editor that behaves like Word</a:t>
             </a:r>
-          </a:p>
-          <a:p>
-            <a:r>
-              <a:t>   (low learning curve for governance owners)</a:t>
-            </a:r>
-          </a:p>
-          <a:p>
-            <a:endParaRPr/>
-          </a:p>
-          <a:p>
-            <a:r>
-              <a:t>3. Import existing governance documents</a:t>
-            </a:r>
-          </a:p>
-          <a:p>
-            <a:r>
-              <a:t>   → validate → publish as OSCAL</a:t>
-            </a:r>
-          </a:p>
-          <a:p>
-            <a:endParaRPr/>
-          </a:p>
-          <a:p>
-            <a:r>
+            <a:r>
+              <a:rPr lang="de-DE" dirty="0"/>
+              <a:t> </a:t>
+            </a:r>
+            <a:r>
+              <a:rPr dirty="0"/>
+              <a:t>(low learning curve for </a:t>
+            </a:r>
+            <a:r>
+              <a:rPr lang="de-DE" dirty="0"/>
+              <a:t>non </a:t>
+            </a:r>
+            <a:r>
+              <a:rPr lang="de-DE" dirty="0" err="1"/>
+              <a:t>technical</a:t>
+            </a:r>
+            <a:r>
+              <a:rPr lang="de-DE" dirty="0"/>
+              <a:t> </a:t>
+            </a:r>
+            <a:r>
+              <a:rPr dirty="0"/>
+              <a:t>governance owners)</a:t>
+            </a:r>
+          </a:p>
+          <a:p>
+            <a:endParaRPr dirty="0"/>
+          </a:p>
+          <a:p>
+            <a:pPr marL="0" indent="0">
+              <a:buNone/>
+            </a:pPr>
+            <a:r>
+              <a:rPr lang="de-DE" dirty="0"/>
+              <a:t>3.</a:t>
+            </a:r>
+            <a:r>
+              <a:rPr dirty="0"/>
+              <a:t> Import existing governance documents</a:t>
+            </a:r>
+            <a:endParaRPr lang="de-DE" dirty="0"/>
+          </a:p>
+          <a:p>
+            <a:pPr marL="0" indent="0">
+              <a:buNone/>
+            </a:pPr>
+            <a:r>
+              <a:rPr lang="de-DE" dirty="0"/>
+              <a:t>	</a:t>
+            </a:r>
+            <a:r>
+              <a:rPr dirty="0"/>
+              <a:t>→ validate → publish as OSCAL</a:t>
+            </a:r>
+          </a:p>
+          <a:p>
+            <a:endParaRPr dirty="0"/>
+          </a:p>
+          <a:p>
+            <a:pPr marL="0" indent="0">
+              <a:buNone/>
+            </a:pPr>
+            <a:r>
+              <a:rPr dirty="0"/>
               <a:t>4. Expand: safety regulations, cross-border (TSI),</a:t>
             </a:r>
-          </a:p>
-          <a:p>
-            <a:r>
-              <a:t>   operational rules</a:t>
-            </a:r>
-          </a:p>
-          <a:p>
-            <a:endParaRPr/>
-          </a:p>
-          <a:p>
-            <a:r>
+            <a:r>
+              <a:rPr lang="de-DE" dirty="0"/>
+              <a:t> </a:t>
+            </a:r>
+            <a:r>
+              <a:rPr dirty="0"/>
+              <a:t>operational rules</a:t>
+            </a:r>
+          </a:p>
+          <a:p>
+            <a:endParaRPr dirty="0"/>
+          </a:p>
+          <a:p>
+            <a:pPr marL="0" indent="0" algn="ctr">
+              <a:buNone/>
+            </a:pPr>
+            <a:endParaRPr sz="3600" dirty="0"/>
+          </a:p>
+        </p:txBody>
+      </p:sp>
+      <p:sp>
+        <p:nvSpPr>
+          <p:cNvPr id="4" name="TextBox 3">
+            <a:extLst>
+              <a:ext uri="{FF2B5EF4-FFF2-40B4-BE49-F238E27FC236}">
+                <a16:creationId xmlns:a16="http://schemas.microsoft.com/office/drawing/2014/main" id="{646D0452-0439-E6B7-5E7E-A087D02FF2EA}"/>
+              </a:ext>
+            </a:extLst>
+          </p:cNvPr>
+          <p:cNvSpPr txBox="1"/>
+          <p:nvPr/>
+        </p:nvSpPr>
+        <p:spPr>
+          <a:xfrm>
+            <a:off x="976184" y="5436973"/>
+            <a:ext cx="9848335" cy="954107"/>
+          </a:xfrm>
+          <a:prstGeom prst="rect">
+            <a:avLst/>
+          </a:prstGeom>
+          <a:noFill/>
+        </p:spPr>
+        <p:txBody>
+          <a:bodyPr wrap="square" rtlCol="0">
+            <a:spAutoFit/>
+          </a:bodyPr>
+          <a:lstStyle/>
+          <a:p>
+            <a:pPr algn="ctr"/>
+            <a:r>
+              <a:rPr lang="en-GB" sz="2800" dirty="0"/>
               <a:t>Little change in workflow. Massive gain in usability.</a:t>
+            </a:r>
+          </a:p>
+          <a:p>
+            <a:pPr algn="ctr"/>
+            <a:r>
+              <a:rPr lang="en-GB" sz="2800" dirty="0"/>
+              <a:t>→ Cross-railway interoperability (DB / SBB / ÖBB / SCNF / …)</a:t>
             </a:r>
           </a:p>
         </p:txBody>
@@ -4209,7 +4923,7 @@
 </file>
 
 <file path=ppt/slides/slide8.xml><?xml version="1.0" encoding="utf-8"?>
-<p:sld xmlns:a="http://schemas.openxmlformats.org/drawingml/2006/main" xmlns:r="http://schemas.openxmlformats.org/officeDocument/2006/relationships" xmlns:p="http://schemas.openxmlformats.org/presentationml/2006/main">
+<p:sld xmlns:a="http://schemas.openxmlformats.org/drawingml/2006/main" xmlns:r="http://schemas.openxmlformats.org/officeDocument/2006/relationships" xmlns:p="http://schemas.openxmlformats.org/presentationml/2006/main" show="0">
   <p:cSld>
     <p:spTree>
       <p:nvGrpSpPr>
@@ -4258,61 +4972,67 @@
         </p:nvSpPr>
         <p:spPr/>
         <p:txBody>
-          <a:bodyPr/>
-          <a:lstStyle/>
-          <a:p>
-            <a:r>
+          <a:bodyPr>
+            <a:normAutofit fontScale="85000" lnSpcReduction="20000"/>
+          </a:bodyPr>
+          <a:lstStyle/>
+          <a:p>
+            <a:r>
+              <a:rPr dirty="0"/>
               <a:t>┌──────────────┐     ┌─────────────┐     ┌──────────────┐</a:t>
             </a:r>
           </a:p>
           <a:p>
             <a:r>
+              <a:rPr dirty="0"/>
               <a:t>│ Web Editor   │ ──► │ OSCAL4Rail  │ ──► │ PDF (view)   │</a:t>
             </a:r>
           </a:p>
           <a:p>
             <a:r>
+              <a:rPr dirty="0"/>
               <a:t>│ (looks like  │     │ (canonical  │     │ API (machine)│</a:t>
             </a:r>
           </a:p>
           <a:p>
             <a:r>
+              <a:rPr dirty="0"/>
               <a:t>│  Word)       │     │  source)    │     │ Diff/Change  │</a:t>
             </a:r>
           </a:p>
           <a:p>
             <a:r>
+              <a:rPr dirty="0"/>
               <a:t>└──────────────┘     └─────────────┘     └──────────────┘</a:t>
             </a:r>
           </a:p>
           <a:p>
-            <a:endParaRPr/>
-          </a:p>
-          <a:p>
-            <a:r>
+            <a:endParaRPr dirty="0"/>
+          </a:p>
+          <a:p>
+            <a:r>
+              <a:rPr dirty="0"/>
               <a:t>Governance owners keep writing like they always have.</a:t>
             </a:r>
           </a:p>
           <a:p>
             <a:r>
+              <a:rPr dirty="0"/>
               <a:t>But the output is structured, versioned, machine-readable.</a:t>
             </a:r>
           </a:p>
           <a:p>
-            <a:endParaRPr/>
-          </a:p>
-          <a:p>
-            <a:r>
-              <a:t>→ Cross-railway interoperability (DB / SBB / ÖBB)</a:t>
-            </a:r>
-          </a:p>
-          <a:p>
-            <a:r>
+            <a:endParaRPr dirty="0"/>
+          </a:p>
+          <a:p>
+            <a:r>
+              <a:rPr dirty="0"/>
               <a:t>→ Automated compliance checks</a:t>
             </a:r>
           </a:p>
           <a:p>
             <a:r>
+              <a:rPr dirty="0"/>
               <a:t>→ Bridge to ACA: contracts validated against regulations</a:t>
             </a:r>
           </a:p>
@@ -4355,7 +5075,7 @@
         </p:nvSpPr>
         <p:spPr/>
         <p:txBody>
-          <a:bodyPr/>
+          <a:bodyPr anchor="t"/>
           <a:lstStyle/>
           <a:p>
             <a:r>
@@ -4375,9 +5095,16 @@
             <p:ph type="subTitle" idx="1"/>
           </p:nvPr>
         </p:nvSpPr>
-        <p:spPr/>
-        <p:txBody>
-          <a:bodyPr/>
+        <p:spPr>
+          <a:xfrm>
+            <a:off x="1731818" y="2601119"/>
+            <a:ext cx="9144000" cy="3134518"/>
+          </a:xfrm>
+        </p:spPr>
+        <p:txBody>
+          <a:bodyPr>
+            <a:normAutofit lnSpcReduction="10000"/>
+          </a:bodyPr>
           <a:lstStyle/>
           <a:p>
             <a:r>
@@ -4741,6 +5468,27 @@
 </file>
 
 <file path=customXml/item1.xml><?xml version="1.0" encoding="utf-8"?>
+<?mso-contentType ?>
+<FormTemplates xmlns="http://schemas.microsoft.com/sharepoint/v3/contenttype/forms">
+  <Display>DocumentLibraryForm</Display>
+  <Edit>DocumentLibraryForm</Edit>
+  <New>DocumentLibraryForm</New>
+</FormTemplates>
+</file>
+
+<file path=customXml/item2.xml><?xml version="1.0" encoding="utf-8"?>
+<p:properties xmlns:p="http://schemas.microsoft.com/office/2006/metadata/properties" xmlns:xsi="http://www.w3.org/2001/XMLSchema-instance" xmlns:pc="http://schemas.microsoft.com/office/infopath/2007/PartnerControls">
+  <documentManagement>
+    <Copyright xmlns="b106c448-c3d1-41cc-8fd9-3acb307364b4" xsi:nil="true"/>
+    <lcf76f155ced4ddcb4097134ff3c332f xmlns="b106c448-c3d1-41cc-8fd9-3acb307364b4">
+      <Terms xmlns="http://schemas.microsoft.com/office/infopath/2007/PartnerControls"/>
+    </lcf76f155ced4ddcb4097134ff3c332f>
+    <TaxCatchAll xmlns="b043894e-b4c8-44d0-9690-d7947297ac19" xsi:nil="true"/>
+  </documentManagement>
+</p:properties>
+</file>
+
+<file path=customXml/item3.xml><?xml version="1.0" encoding="utf-8"?>
 <ct:contentTypeSchema xmlns:ct="http://schemas.microsoft.com/office/2006/metadata/contentType" xmlns:ma="http://schemas.microsoft.com/office/2006/metadata/properties/metaAttributes" ct:_="" ma:_="" ma:contentTypeName="Dokument" ma:contentTypeID="0x010100C5895299445B8C4DB378BBB718B1F939" ma:contentTypeVersion="18" ma:contentTypeDescription="Ein neues Dokument erstellen." ma:contentTypeScope="" ma:versionID="ca18c32604eb9eb075bdd5b520f76d7f">
   <xsd:schema xmlns:xsd="http://www.w3.org/2001/XMLSchema" xmlns:xs="http://www.w3.org/2001/XMLSchema" xmlns:p="http://schemas.microsoft.com/office/2006/metadata/properties" xmlns:ns2="b106c448-c3d1-41cc-8fd9-3acb307364b4" xmlns:ns3="b043894e-b4c8-44d0-9690-d7947297ac19" targetNamespace="http://schemas.microsoft.com/office/2006/metadata/properties" ma:root="true" ma:fieldsID="0e0a0918b2fa3636e306fde1bc5c258b" ns2:_="" ns3:_="">
     <xsd:import namespace="b106c448-c3d1-41cc-8fd9-3acb307364b4"/>
@@ -4985,42 +5733,10 @@
 </ct:contentTypeSchema>
 </file>
 
-<file path=customXml/item2.xml><?xml version="1.0" encoding="utf-8"?>
-<p:properties xmlns:p="http://schemas.microsoft.com/office/2006/metadata/properties" xmlns:xsi="http://www.w3.org/2001/XMLSchema-instance" xmlns:pc="http://schemas.microsoft.com/office/infopath/2007/PartnerControls">
-  <documentManagement>
-    <Copyright xmlns="b106c448-c3d1-41cc-8fd9-3acb307364b4" xsi:nil="true"/>
-    <lcf76f155ced4ddcb4097134ff3c332f xmlns="b106c448-c3d1-41cc-8fd9-3acb307364b4">
-      <Terms xmlns="http://schemas.microsoft.com/office/infopath/2007/PartnerControls"/>
-    </lcf76f155ced4ddcb4097134ff3c332f>
-    <TaxCatchAll xmlns="b043894e-b4c8-44d0-9690-d7947297ac19" xsi:nil="true"/>
-  </documentManagement>
-</p:properties>
-</file>
-
-<file path=customXml/item3.xml><?xml version="1.0" encoding="utf-8"?>
-<?mso-contentType ?>
-<FormTemplates xmlns="http://schemas.microsoft.com/sharepoint/v3/contenttype/forms">
-  <Display>DocumentLibraryForm</Display>
-  <Edit>DocumentLibraryForm</Edit>
-  <New>DocumentLibraryForm</New>
-</FormTemplates>
-</file>
-
 <file path=customXml/itemProps1.xml><?xml version="1.0" encoding="utf-8"?>
-<ds:datastoreItem xmlns:ds="http://schemas.openxmlformats.org/officeDocument/2006/customXml" ds:itemID="{0BED3A9D-D1E4-45EA-8B49-CB6F60C2A98A}">
+<ds:datastoreItem xmlns:ds="http://schemas.openxmlformats.org/officeDocument/2006/customXml" ds:itemID="{47CF5FD6-43E2-4C9A-9372-C9D60EE1772B}">
   <ds:schemaRefs>
-    <ds:schemaRef ds:uri="http://schemas.microsoft.com/office/2006/metadata/contentType"/>
-    <ds:schemaRef ds:uri="http://schemas.microsoft.com/office/2006/metadata/properties/metaAttributes"/>
-    <ds:schemaRef ds:uri="http://www.w3.org/2001/XMLSchema"/>
-    <ds:schemaRef ds:uri="http://schemas.microsoft.com/office/2006/metadata/properties"/>
-    <ds:schemaRef ds:uri="b106c448-c3d1-41cc-8fd9-3acb307364b4"/>
-    <ds:schemaRef ds:uri="b043894e-b4c8-44d0-9690-d7947297ac19"/>
-    <ds:schemaRef ds:uri="http://schemas.microsoft.com/office/2006/documentManagement/types"/>
-    <ds:schemaRef ds:uri="http://schemas.microsoft.com/office/infopath/2007/PartnerControls"/>
-    <ds:schemaRef ds:uri="http://schemas.openxmlformats.org/package/2006/metadata/core-properties"/>
-    <ds:schemaRef ds:uri="http://purl.org/dc/elements/1.1/"/>
-    <ds:schemaRef ds:uri="http://purl.org/dc/terms/"/>
-    <ds:schemaRef ds:uri="http://schemas.microsoft.com/internal/obd"/>
+    <ds:schemaRef ds:uri="http://schemas.microsoft.com/sharepoint/v3/contenttype/forms"/>
   </ds:schemaRefs>
 </ds:datastoreItem>
 </file>
@@ -5043,9 +5759,20 @@
 </file>
 
 <file path=customXml/itemProps3.xml><?xml version="1.0" encoding="utf-8"?>
-<ds:datastoreItem xmlns:ds="http://schemas.openxmlformats.org/officeDocument/2006/customXml" ds:itemID="{47CF5FD6-43E2-4C9A-9372-C9D60EE1772B}">
+<ds:datastoreItem xmlns:ds="http://schemas.openxmlformats.org/officeDocument/2006/customXml" ds:itemID="{0BED3A9D-D1E4-45EA-8B49-CB6F60C2A98A}">
   <ds:schemaRefs>
-    <ds:schemaRef ds:uri="http://schemas.microsoft.com/sharepoint/v3/contenttype/forms"/>
+    <ds:schemaRef ds:uri="http://schemas.microsoft.com/office/2006/metadata/contentType"/>
+    <ds:schemaRef ds:uri="http://schemas.microsoft.com/office/2006/metadata/properties/metaAttributes"/>
+    <ds:schemaRef ds:uri="http://www.w3.org/2001/XMLSchema"/>
+    <ds:schemaRef ds:uri="http://schemas.microsoft.com/office/2006/metadata/properties"/>
+    <ds:schemaRef ds:uri="b106c448-c3d1-41cc-8fd9-3acb307364b4"/>
+    <ds:schemaRef ds:uri="b043894e-b4c8-44d0-9690-d7947297ac19"/>
+    <ds:schemaRef ds:uri="http://schemas.microsoft.com/office/2006/documentManagement/types"/>
+    <ds:schemaRef ds:uri="http://schemas.microsoft.com/office/infopath/2007/PartnerControls"/>
+    <ds:schemaRef ds:uri="http://schemas.openxmlformats.org/package/2006/metadata/core-properties"/>
+    <ds:schemaRef ds:uri="http://purl.org/dc/elements/1.1/"/>
+    <ds:schemaRef ds:uri="http://purl.org/dc/terms/"/>
+    <ds:schemaRef ds:uri="http://schemas.microsoft.com/internal/obd"/>
   </ds:schemaRefs>
 </ds:datastoreItem>
 </file>

</xml_diff>